<commit_message>
Re: Figure 4 panel
y-label of 4e changed
</commit_message>
<xml_diff>
--- a/Figure4/Panel_Figure4/Fig4.pptx
+++ b/Figure4/Panel_Figure4/Fig4.pptx
@@ -197,7 +197,7 @@
           <a:p>
             <a:fld id="{79CDCA09-FA9A-FE47-A967-C142DA2AD5FF}" type="datetimeFigureOut">
               <a:rPr lang="en-US" smtClean="0"/>
-              <a:t>12/12/25</a:t>
+              <a:t>5/4/26</a:t>
             </a:fld>
             <a:endParaRPr lang="en-US"/>
           </a:p>
@@ -464,6 +464,90 @@
 </p:notesMaster>
 </file>
 
+<file path=ppt/notesSlides/notesSlide1.xml><?xml version="1.0" encoding="utf-8"?>
+<p:notes xmlns:a="http://schemas.openxmlformats.org/drawingml/2006/main" xmlns:r="http://schemas.openxmlformats.org/officeDocument/2006/relationships" xmlns:p="http://schemas.openxmlformats.org/presentationml/2006/main">
+  <p:cSld>
+    <p:spTree>
+      <p:nvGrpSpPr>
+        <p:cNvPr id="1" name=""/>
+        <p:cNvGrpSpPr/>
+        <p:nvPr/>
+      </p:nvGrpSpPr>
+      <p:grpSpPr>
+        <a:xfrm>
+          <a:off x="0" y="0"/>
+          <a:ext cx="0" cy="0"/>
+          <a:chOff x="0" y="0"/>
+          <a:chExt cx="0" cy="0"/>
+        </a:xfrm>
+      </p:grpSpPr>
+      <p:sp>
+        <p:nvSpPr>
+          <p:cNvPr id="2" name="Slide Image Placeholder 1"/>
+          <p:cNvSpPr>
+            <a:spLocks noGrp="1" noRot="1" noChangeAspect="1"/>
+          </p:cNvSpPr>
+          <p:nvPr>
+            <p:ph type="sldImg"/>
+          </p:nvPr>
+        </p:nvSpPr>
+        <p:spPr/>
+      </p:sp>
+      <p:sp>
+        <p:nvSpPr>
+          <p:cNvPr id="3" name="Notes Placeholder 2"/>
+          <p:cNvSpPr>
+            <a:spLocks noGrp="1"/>
+          </p:cNvSpPr>
+          <p:nvPr>
+            <p:ph type="body" idx="1"/>
+          </p:nvPr>
+        </p:nvSpPr>
+        <p:spPr/>
+        <p:txBody>
+          <a:bodyPr/>
+          <a:lstStyle/>
+          <a:p>
+            <a:endParaRPr lang="en-US" dirty="0"/>
+          </a:p>
+        </p:txBody>
+      </p:sp>
+      <p:sp>
+        <p:nvSpPr>
+          <p:cNvPr id="4" name="Slide Number Placeholder 3"/>
+          <p:cNvSpPr>
+            <a:spLocks noGrp="1"/>
+          </p:cNvSpPr>
+          <p:nvPr>
+            <p:ph type="sldNum" sz="quarter" idx="5"/>
+          </p:nvPr>
+        </p:nvSpPr>
+        <p:spPr/>
+        <p:txBody>
+          <a:bodyPr/>
+          <a:lstStyle/>
+          <a:p>
+            <a:fld id="{02A46927-0C4B-CB48-8FF7-FEA4D470ABF5}" type="slidenum">
+              <a:rPr lang="en-US" smtClean="0"/>
+              <a:t>1</a:t>
+            </a:fld>
+            <a:endParaRPr lang="en-US"/>
+          </a:p>
+        </p:txBody>
+      </p:sp>
+    </p:spTree>
+    <p:extLst>
+      <p:ext uri="{BB962C8B-B14F-4D97-AF65-F5344CB8AC3E}">
+        <p14:creationId xmlns:p14="http://schemas.microsoft.com/office/powerpoint/2010/main" val="1446447508"/>
+      </p:ext>
+    </p:extLst>
+  </p:cSld>
+  <p:clrMapOvr>
+    <a:masterClrMapping/>
+  </p:clrMapOvr>
+</p:notes>
+</file>
+
 <file path=ppt/slideLayouts/slideLayout1.xml><?xml version="1.0" encoding="utf-8"?>
 <p:sldLayout xmlns:a="http://schemas.openxmlformats.org/drawingml/2006/main" xmlns:r="http://schemas.openxmlformats.org/officeDocument/2006/relationships" xmlns:p="http://schemas.openxmlformats.org/presentationml/2006/main" type="title" preserve="1">
   <p:cSld name="Title Slide">
@@ -595,7 +679,7 @@
           <a:p>
             <a:fld id="{ADC70F63-332C-3848-8FC4-A5AA61D38FDB}" type="datetimeFigureOut">
               <a:rPr lang="en-US" smtClean="0"/>
-              <a:t>12/12/25</a:t>
+              <a:t>5/4/26</a:t>
             </a:fld>
             <a:endParaRPr lang="en-US"/>
           </a:p>
@@ -765,7 +849,7 @@
           <a:p>
             <a:fld id="{ADC70F63-332C-3848-8FC4-A5AA61D38FDB}" type="datetimeFigureOut">
               <a:rPr lang="en-US" smtClean="0"/>
-              <a:t>12/12/25</a:t>
+              <a:t>5/4/26</a:t>
             </a:fld>
             <a:endParaRPr lang="en-US"/>
           </a:p>
@@ -945,7 +1029,7 @@
           <a:p>
             <a:fld id="{ADC70F63-332C-3848-8FC4-A5AA61D38FDB}" type="datetimeFigureOut">
               <a:rPr lang="en-US" smtClean="0"/>
-              <a:t>12/12/25</a:t>
+              <a:t>5/4/26</a:t>
             </a:fld>
             <a:endParaRPr lang="en-US"/>
           </a:p>
@@ -1115,7 +1199,7 @@
           <a:p>
             <a:fld id="{ADC70F63-332C-3848-8FC4-A5AA61D38FDB}" type="datetimeFigureOut">
               <a:rPr lang="en-US" smtClean="0"/>
-              <a:t>12/12/25</a:t>
+              <a:t>5/4/26</a:t>
             </a:fld>
             <a:endParaRPr lang="en-US"/>
           </a:p>
@@ -1361,7 +1445,7 @@
           <a:p>
             <a:fld id="{ADC70F63-332C-3848-8FC4-A5AA61D38FDB}" type="datetimeFigureOut">
               <a:rPr lang="en-US" smtClean="0"/>
-              <a:t>12/12/25</a:t>
+              <a:t>5/4/26</a:t>
             </a:fld>
             <a:endParaRPr lang="en-US"/>
           </a:p>
@@ -1593,7 +1677,7 @@
           <a:p>
             <a:fld id="{ADC70F63-332C-3848-8FC4-A5AA61D38FDB}" type="datetimeFigureOut">
               <a:rPr lang="en-US" smtClean="0"/>
-              <a:t>12/12/25</a:t>
+              <a:t>5/4/26</a:t>
             </a:fld>
             <a:endParaRPr lang="en-US"/>
           </a:p>
@@ -1960,7 +2044,7 @@
           <a:p>
             <a:fld id="{ADC70F63-332C-3848-8FC4-A5AA61D38FDB}" type="datetimeFigureOut">
               <a:rPr lang="en-US" smtClean="0"/>
-              <a:t>12/12/25</a:t>
+              <a:t>5/4/26</a:t>
             </a:fld>
             <a:endParaRPr lang="en-US"/>
           </a:p>
@@ -2078,7 +2162,7 @@
           <a:p>
             <a:fld id="{ADC70F63-332C-3848-8FC4-A5AA61D38FDB}" type="datetimeFigureOut">
               <a:rPr lang="en-US" smtClean="0"/>
-              <a:t>12/12/25</a:t>
+              <a:t>5/4/26</a:t>
             </a:fld>
             <a:endParaRPr lang="en-US"/>
           </a:p>
@@ -2173,7 +2257,7 @@
           <a:p>
             <a:fld id="{ADC70F63-332C-3848-8FC4-A5AA61D38FDB}" type="datetimeFigureOut">
               <a:rPr lang="en-US" smtClean="0"/>
-              <a:t>12/12/25</a:t>
+              <a:t>5/4/26</a:t>
             </a:fld>
             <a:endParaRPr lang="en-US"/>
           </a:p>
@@ -2450,7 +2534,7 @@
           <a:p>
             <a:fld id="{ADC70F63-332C-3848-8FC4-A5AA61D38FDB}" type="datetimeFigureOut">
               <a:rPr lang="en-US" smtClean="0"/>
-              <a:t>12/12/25</a:t>
+              <a:t>5/4/26</a:t>
             </a:fld>
             <a:endParaRPr lang="en-US"/>
           </a:p>
@@ -2707,7 +2791,7 @@
           <a:p>
             <a:fld id="{ADC70F63-332C-3848-8FC4-A5AA61D38FDB}" type="datetimeFigureOut">
               <a:rPr lang="en-US" smtClean="0"/>
-              <a:t>12/12/25</a:t>
+              <a:t>5/4/26</a:t>
             </a:fld>
             <a:endParaRPr lang="en-US"/>
           </a:p>
@@ -2920,7 +3004,7 @@
           <a:p>
             <a:fld id="{ADC70F63-332C-3848-8FC4-A5AA61D38FDB}" type="datetimeFigureOut">
               <a:rPr lang="en-US" smtClean="0"/>
-              <a:t>12/12/25</a:t>
+              <a:t>5/4/26</a:t>
             </a:fld>
             <a:endParaRPr lang="en-US"/>
           </a:p>
@@ -3340,7 +3424,7 @@
           <p:nvPr/>
         </p:nvPicPr>
         <p:blipFill>
-          <a:blip r:embed="rId2"/>
+          <a:blip r:embed="rId3"/>
           <a:stretch>
             <a:fillRect/>
           </a:stretch>
@@ -3355,8 +3439,8 @@
           </a:prstGeom>
         </p:spPr>
       </p:pic>
-      <mc:AlternateContent xmlns:mc="http://schemas.openxmlformats.org/markup-compatibility/2006">
-        <mc:Choice xmlns:a14="http://schemas.microsoft.com/office/drawing/2010/main" Requires="a14">
+      <mc:AlternateContent xmlns:mc="http://schemas.openxmlformats.org/markup-compatibility/2006" xmlns:a14="http://schemas.microsoft.com/office/drawing/2010/main">
+        <mc:Choice Requires="a14">
           <p:sp>
             <p:nvSpPr>
               <p:cNvPr id="6" name="TextBox 5">
@@ -3402,6 +3486,7 @@
                         <a:solidFill>
                           <a:schemeClr val="tx1"/>
                         </a:solidFill>
+                        <a:latin typeface="Cambria Math" panose="02040503050406030204" pitchFamily="18" charset="0"/>
                         <a:ea typeface="Cambria Math" panose="02040503050406030204" pitchFamily="18" charset="0"/>
                       </a:rPr>
                       <m:t>≥</m:t>
@@ -3420,7 +3505,7 @@
             </p:txBody>
           </p:sp>
         </mc:Choice>
-        <mc:Fallback>
+        <mc:Fallback xmlns="">
           <p:sp>
             <p:nvSpPr>
               <p:cNvPr id="6" name="TextBox 5">
@@ -3444,7 +3529,7 @@
                 <a:avLst/>
               </a:prstGeom>
               <a:blipFill>
-                <a:blip r:embed="rId3"/>
+                <a:blip r:embed="rId4"/>
                 <a:stretch>
                   <a:fillRect r="-637" b="-3571"/>
                 </a:stretch>
@@ -3516,7 +3601,7 @@
           <p:nvPr/>
         </p:nvPicPr>
         <p:blipFill>
-          <a:blip r:embed="rId4"/>
+          <a:blip r:embed="rId5"/>
           <a:stretch>
             <a:fillRect/>
           </a:stretch>
@@ -3546,7 +3631,7 @@
           <p:nvPr/>
         </p:nvPicPr>
         <p:blipFill>
-          <a:blip r:embed="rId5"/>
+          <a:blip r:embed="rId6"/>
           <a:stretch>
             <a:fillRect/>
           </a:stretch>
@@ -3627,6 +3712,101 @@
             <a:r>
               <a:rPr lang="en-US" b="1" dirty="0"/>
               <a:t>e</a:t>
+            </a:r>
+          </a:p>
+        </p:txBody>
+      </p:sp>
+      <p:sp>
+        <p:nvSpPr>
+          <p:cNvPr id="3" name="Rectangle 2">
+            <a:extLst>
+              <a:ext uri="{FF2B5EF4-FFF2-40B4-BE49-F238E27FC236}">
+                <a16:creationId xmlns:a16="http://schemas.microsoft.com/office/drawing/2014/main" id="{25D41FF5-6DE9-F56D-C94D-7706151985FC}"/>
+              </a:ext>
+            </a:extLst>
+          </p:cNvPr>
+          <p:cNvSpPr/>
+          <p:nvPr/>
+        </p:nvSpPr>
+        <p:spPr>
+          <a:xfrm>
+            <a:off x="3318093" y="3503141"/>
+            <a:ext cx="156435" cy="1662921"/>
+          </a:xfrm>
+          <a:prstGeom prst="rect">
+            <a:avLst/>
+          </a:prstGeom>
+          <a:solidFill>
+            <a:schemeClr val="bg1"/>
+          </a:solidFill>
+          <a:ln>
+            <a:noFill/>
+          </a:ln>
+        </p:spPr>
+        <p:style>
+          <a:lnRef idx="2">
+            <a:schemeClr val="accent1">
+              <a:shade val="15000"/>
+            </a:schemeClr>
+          </a:lnRef>
+          <a:fillRef idx="1">
+            <a:schemeClr val="accent1"/>
+          </a:fillRef>
+          <a:effectRef idx="0">
+            <a:schemeClr val="accent1"/>
+          </a:effectRef>
+          <a:fontRef idx="minor">
+            <a:schemeClr val="lt1"/>
+          </a:fontRef>
+        </p:style>
+        <p:txBody>
+          <a:bodyPr rtlCol="0" anchor="ctr"/>
+          <a:lstStyle/>
+          <a:p>
+            <a:pPr algn="ctr"/>
+            <a:endParaRPr lang="en-US"/>
+          </a:p>
+        </p:txBody>
+      </p:sp>
+      <p:sp>
+        <p:nvSpPr>
+          <p:cNvPr id="2" name="TextBox 1">
+            <a:extLst>
+              <a:ext uri="{FF2B5EF4-FFF2-40B4-BE49-F238E27FC236}">
+                <a16:creationId xmlns:a16="http://schemas.microsoft.com/office/drawing/2014/main" id="{58780785-4440-876E-E22B-6D6134C76344}"/>
+              </a:ext>
+            </a:extLst>
+          </p:cNvPr>
+          <p:cNvSpPr txBox="1"/>
+          <p:nvPr/>
+        </p:nvSpPr>
+        <p:spPr>
+          <a:xfrm rot="16200000">
+            <a:off x="2611834" y="4193237"/>
+            <a:ext cx="1531190" cy="209847"/>
+          </a:xfrm>
+          <a:prstGeom prst="rect">
+            <a:avLst/>
+          </a:prstGeom>
+          <a:noFill/>
+        </p:spPr>
+        <p:txBody>
+          <a:bodyPr wrap="square" rtlCol="0">
+            <a:spAutoFit/>
+          </a:bodyPr>
+          <a:lstStyle/>
+          <a:p>
+            <a:pPr algn="ctr"/>
+            <a:r>
+              <a:rPr lang="en-US" sz="900" dirty="0">
+                <a:solidFill>
+                  <a:schemeClr val="tx1">
+                    <a:lumMod val="85000"/>
+                    <a:lumOff val="15000"/>
+                  </a:schemeClr>
+                </a:solidFill>
+              </a:rPr>
+              <a:t>Maximum Population Size</a:t>
             </a:r>
           </a:p>
         </p:txBody>

</xml_diff>